<commit_message>
Update PPTX to reflect changes to plot.py
</commit_message>
<xml_diff>
--- a/Y1_Kinetics/Kinetics with Python.pptx
+++ b/Y1_Kinetics/Kinetics with Python.pptx
@@ -10470,7 +10470,7 @@
         </p:spPr>
         <p:txBody>
           <a:bodyPr anchorCtr="0" anchor="t" bIns="40825" lIns="81650" spcFirstLastPara="1" rIns="81650" wrap="square" tIns="40825">
-            <a:normAutofit/>
+            <a:normAutofit lnSpcReduction="10000"/>
           </a:bodyPr>
           <a:lstStyle/>
           <a:p>
@@ -10490,6 +10490,30 @@
             <a:r>
               <a:rPr lang="en-GB"/>
               <a:t>Handling multiple data files with Python</a:t>
+            </a:r>
+            <a:endParaRPr/>
+          </a:p>
+          <a:p>
+            <a:pPr indent="0" lvl="0" marL="0" rtl="0" algn="l">
+              <a:spcBef>
+                <a:spcPts val="0"/>
+              </a:spcBef>
+              <a:spcAft>
+                <a:spcPts val="0"/>
+              </a:spcAft>
+              <a:buClr>
+                <a:srgbClr val="25303B"/>
+              </a:buClr>
+              <a:buSzPts val="3000"/>
+              <a:buNone/>
+            </a:pPr>
+            <a:r>
+              <a:rPr lang="en-GB"/>
+              <a:t>CheckIn: </a:t>
+            </a:r>
+            <a:r>
+              <a:rPr lang="en-GB"/>
+              <a:t>809296</a:t>
             </a:r>
             <a:endParaRPr/>
           </a:p>
@@ -12222,11 +12246,7 @@
             </a:pPr>
             <a:r>
               <a:rPr i="1" lang="en-GB"/>
-              <a:t># </a:t>
-            </a:r>
-            <a:r>
-              <a:rPr i="1" lang="en-GB"/>
-              <a:t>suffix = '_suffix’</a:t>
+              <a:t>suffix = “”</a:t>
             </a:r>
             <a:endParaRPr/>
           </a:p>
@@ -12247,7 +12267,7 @@
             </a:pPr>
             <a:r>
               <a:rPr lang="en-GB"/>
-              <a:t>We can change this output as we use the script for different purposes</a:t>
+              <a:t>This is blank by default - an empty string.</a:t>
             </a:r>
             <a:endParaRPr/>
           </a:p>
@@ -12268,7 +12288,7 @@
             </a:pPr>
             <a:r>
               <a:rPr lang="en-GB"/>
-              <a:t>Right now we’re creating ‘raw data’ plots and we will go onto creating linearised plots</a:t>
+              <a:t>We can change this output as we use the script for different purposes</a:t>
             </a:r>
             <a:endParaRPr/>
           </a:p>
@@ -12289,7 +12309,28 @@
             </a:pPr>
             <a:r>
               <a:rPr lang="en-GB"/>
-              <a:t>We can change the suffix to reflect the files we’re creating</a:t>
+              <a:t>Right now we’re creating ‘raw data’ plots and we will go onto creating linearised plots</a:t>
+            </a:r>
+            <a:endParaRPr/>
+          </a:p>
+          <a:p>
+            <a:pPr indent="-285750" lvl="0" marL="285750" rtl="0" algn="l">
+              <a:spcBef>
+                <a:spcPts val="360"/>
+              </a:spcBef>
+              <a:spcAft>
+                <a:spcPts val="0"/>
+              </a:spcAft>
+              <a:buClr>
+                <a:srgbClr val="25303B"/>
+              </a:buClr>
+              <a:buSzPts val="1800"/>
+              <a:buFont typeface="Noto Sans Symbols"/>
+              <a:buChar char="▪"/>
+            </a:pPr>
+            <a:r>
+              <a:rPr lang="en-GB"/>
+              <a:t>We can change the suffix to reflect the files we’re creating by adding something inside the quotation marks.</a:t>
             </a:r>
             <a:endParaRPr/>
           </a:p>
@@ -12696,6 +12737,23 @@
               <a:spcAft>
                 <a:spcPts val="0"/>
               </a:spcAft>
+              <a:buSzPts val="1800"/>
+              <a:buChar char="▪"/>
+            </a:pPr>
+            <a:r>
+              <a:rPr b="1" lang="en-GB"/>
+              <a:t>CheckIn: 809296</a:t>
+            </a:r>
+            <a:endParaRPr b="1"/>
+          </a:p>
+          <a:p>
+            <a:pPr indent="-285750" lvl="0" marL="285750" rtl="0" algn="l">
+              <a:spcBef>
+                <a:spcPts val="0"/>
+              </a:spcBef>
+              <a:spcAft>
+                <a:spcPts val="0"/>
+              </a:spcAft>
               <a:buClr>
                 <a:srgbClr val="25303B"/>
               </a:buClr>
@@ -12792,7 +12850,7 @@
                 </a:solidFill>
                 <a:hlinkClick r:id="rId3"/>
               </a:rPr>
-              <a:t>https://chemtl.york.ac.uk/data-analysis-reporting/data-manipulation/python</a:t>
+              <a:t>https://chemtl.york.ac.uk/data-analysis-reporting/python/graphs</a:t>
             </a:r>
             <a:endParaRPr sz="1400"/>
           </a:p>
@@ -14985,7 +15043,7 @@
             </a:r>
             <a:r>
               <a:rPr lang="en-GB"/>
-              <a:t> arrhenius</a:t>
+              <a:t>arrhenius</a:t>
             </a:r>
             <a:r>
               <a:rPr i="1" lang="en-GB"/>
@@ -17149,7 +17207,7 @@
               <a:alphaModFix/>
             </a:blip>
             <a:stretch>
-              <a:fillRect b="-2631" l="-624" r="0" t="0"/>
+              <a:fillRect b="-2631" l="-626" r="0" t="0"/>
             </a:stretch>
           </a:blipFill>
           <a:ln>
@@ -17203,7 +17261,7 @@
               <a:alphaModFix/>
             </a:blip>
             <a:stretch>
-              <a:fillRect b="-17102" l="0" r="-545" t="0"/>
+              <a:fillRect b="-17104" l="0" r="-546" t="0"/>
             </a:stretch>
           </a:blipFill>
           <a:ln>
@@ -17257,7 +17315,7 @@
               <a:alphaModFix/>
             </a:blip>
             <a:stretch>
-              <a:fillRect b="-17102" l="0" r="0" t="0"/>
+              <a:fillRect b="-17104" l="0" r="0" t="0"/>
             </a:stretch>
           </a:blipFill>
           <a:ln>
@@ -17730,7 +17788,7 @@
               <a:alphaModFix/>
             </a:blip>
             <a:stretch>
-              <a:fillRect b="-16665" l="0" r="0" t="0"/>
+              <a:fillRect b="-16666" l="0" r="0" t="0"/>
             </a:stretch>
           </a:blipFill>
           <a:ln>
@@ -18808,7 +18866,7 @@
             </a:pPr>
             <a:r>
               <a:rPr lang="en-GB"/>
-              <a:t>Open Powershell: hold shift, right click in the folder, and select “Open PowerShell window here”.</a:t>
+              <a:t>Open a Terminal: right click in the folder, and select “Open in Terminal”.</a:t>
             </a:r>
             <a:endParaRPr/>
           </a:p>
@@ -19749,7 +19807,7 @@
               <a:alphaModFix/>
             </a:blip>
             <a:stretch>
-              <a:fillRect b="0" l="-301" r="0" t="0"/>
+              <a:fillRect b="0" l="-302" r="0" t="0"/>
             </a:stretch>
           </a:blipFill>
           <a:ln>

</xml_diff>